<commit_message>
docs: actualizar presentacion, informe y capturas a arquitectura microservicios
</commit_message>
<xml_diff>
--- a/Entrega-Final-EP2/Presentacion-Semestral-EP2.pptx
+++ b/Entrega-Final-EP2/Presentacion-Semestral-EP2.pptx
@@ -3146,7 +3146,7 @@
           </a:p>
           <a:p>
             <a:r>
-              <a:t>Despliegue Automatizado en AWS</a:t>
+              <a:t>Arquitectura Java Spring Boot &amp; React Vite en AWS</a:t>
             </a:r>
           </a:p>
         </p:txBody>
@@ -3206,22 +3206,22 @@
           <a:lstStyle/>
           <a:p>
             <a:r>
-              <a:t>1. Navegación al Frontend en IP Pública.</a:t>
-            </a:r>
-          </a:p>
-          <a:p>
-            <a:r>
-              <a:t>2. Inserción de productos (Verificación de Backend).</a:t>
-            </a:r>
-          </a:p>
-          <a:p>
-            <a:r>
-              <a:t>3. Eliminación de Contenedores y Recuperación (Verificación de Persistencia).</a:t>
-            </a:r>
-          </a:p>
-          <a:p>
-            <a:r>
-              <a:t>4. Despliegue automático tras Git Push.</a:t>
+              <a:t>1. Navegación en Frontend React.</a:t>
+            </a:r>
+          </a:p>
+          <a:p>
+            <a:r>
+              <a:t>2. Verificación de logs en Backends Java.</a:t>
+            </a:r>
+          </a:p>
+          <a:p>
+            <a:r>
+              <a:t>3. Recuperación de base de datos MySQL (Named Volume).</a:t>
+            </a:r>
+          </a:p>
+          <a:p>
+            <a:r>
+              <a:t>4. Despliegue CI/CD automático tras Git Push.</a:t>
             </a:r>
           </a:p>
         </p:txBody>
@@ -3268,7 +3268,7 @@
               </a:defRPr>
             </a:pPr>
             <a:r>
-              <a:t>Contexto del Proyecto: Innovatech Chile</a:t>
+              <a:t>Contexto: Proyecto Semestral</a:t>
             </a:r>
           </a:p>
         </p:txBody>
@@ -3301,7 +3301,7 @@
               </a:defRPr>
             </a:pPr>
             <a:r>
-              <a:t>Objetivo: Desplegar la aplicación 'Tienda de Perritos' en AWS.</a:t>
+              <a:t>Objetivo: Desplegar plataforma de microservicios en AWS.</a:t>
             </a:r>
           </a:p>
           <a:p>
@@ -3317,7 +3317,7 @@
               </a:defRPr>
             </a:pPr>
             <a:r>
-              <a:t>Requerimientos Clave:</a:t>
+              <a:t>Arquitectura:</a:t>
             </a:r>
           </a:p>
           <a:p>
@@ -3333,7 +3333,7 @@
               </a:defRPr>
             </a:pPr>
             <a:r>
-              <a:t>1. Contenedorización de Frontend y Backend.</a:t>
+              <a:t>1. Frontend React (Vite).</a:t>
             </a:r>
           </a:p>
           <a:p>
@@ -3349,7 +3349,7 @@
               </a:defRPr>
             </a:pPr>
             <a:r>
-              <a:t>2. Persistencia de datos crítica.</a:t>
+              <a:t>2. Backend Ventas (Java Spring Boot).</a:t>
             </a:r>
           </a:p>
           <a:p>
@@ -3365,7 +3365,7 @@
               </a:defRPr>
             </a:pPr>
             <a:r>
-              <a:t>3. Pipeline CI/CD en GitHub Actions.</a:t>
+              <a:t>3. Backend Despachos (Java Spring Boot).</a:t>
             </a:r>
           </a:p>
           <a:p>
@@ -3381,7 +3381,23 @@
               </a:defRPr>
             </a:pPr>
             <a:r>
-              <a:t>4. Funcionamiento y Comunicación Segura en EC2.</a:t>
+              <a:t>4. Database MySQL compartida.</a:t>
+            </a:r>
+          </a:p>
+          <a:p>
+            <a:pPr>
+              <a:spcAft>
+                <a:spcPts val="1400"/>
+              </a:spcAft>
+              <a:defRPr sz="2000">
+                <a:solidFill>
+                  <a:srgbClr val="3C3C3C"/>
+                </a:solidFill>
+                <a:latin typeface="Arial"/>
+              </a:defRPr>
+            </a:pPr>
+            <a:r>
+              <a:t>Automatización total vía GitHub Actions a Amazon EC2.</a:t>
             </a:r>
           </a:p>
         </p:txBody>
@@ -3461,7 +3477,7 @@
               </a:defRPr>
             </a:pPr>
             <a:r>
-              <a:t>Backend (Node.js):</a:t>
+              <a:t>Backends (Java Maven):</a:t>
             </a:r>
           </a:p>
           <a:p>
@@ -3477,7 +3493,7 @@
               </a:defRPr>
             </a:pPr>
             <a:r>
-              <a:t>• Multi-stage build: Reduce tamaño aislando dependencias.</a:t>
+              <a:t>• Multi-stage: 'maven' compila, 'temurin-jre-alpine' corre.</a:t>
             </a:r>
           </a:p>
           <a:p>
@@ -3493,7 +3509,7 @@
               </a:defRPr>
             </a:pPr>
             <a:r>
-              <a:t>• Seguridad: Ejecutado con usuario 'node' (non-root).</a:t>
+              <a:t>• Seguridad: Ejecutados con usuario 'spring' (non-root).</a:t>
             </a:r>
           </a:p>
           <a:p>
@@ -3522,7 +3538,7 @@
               </a:defRPr>
             </a:pPr>
             <a:r>
-              <a:t>Frontend (Nginx):</a:t>
+              <a:t>Frontend (React Vite):</a:t>
             </a:r>
           </a:p>
           <a:p>
@@ -3538,7 +3554,7 @@
               </a:defRPr>
             </a:pPr>
             <a:r>
-              <a:t>• Multi-stage build: Compilación y Servidor.</a:t>
+              <a:t>• Multi-stage: 'node' compila, Nginx sirve estáticos.</a:t>
             </a:r>
           </a:p>
           <a:p>
@@ -3570,7 +3586,7 @@
               </a:defRPr>
             </a:pPr>
             <a:r>
-              <a:t>• Optimización: Uso de imágenes Alpine Linux.</a:t>
+              <a:t>• Enrutamiento: Nginx actúa como Proxy Reverso (/api/*).</a:t>
             </a:r>
           </a:p>
         </p:txBody>
@@ -3650,7 +3666,7 @@
               </a:defRPr>
             </a:pPr>
             <a:r>
-              <a:t>Red Interna: 'app-network' (Bridge DNS discovery).</a:t>
+              <a:t>Orquestación (4 Servicios):</a:t>
             </a:r>
           </a:p>
           <a:p>
@@ -3666,7 +3682,7 @@
               </a:defRPr>
             </a:pPr>
             <a:r>
-              <a:t>Dependencias Seguras: Backend no inicia sin 'service_healthy' de DB.</a:t>
+              <a:t>• Red Interna: 'app-network' aísla microservicios.</a:t>
             </a:r>
           </a:p>
           <a:p>
@@ -3698,7 +3714,7 @@
               </a:defRPr>
             </a:pPr>
             <a:r>
-              <a:t>• Elección: Named Volume ('db_data').</a:t>
+              <a:t>• Elección: Named Volume ('tienda_db_data').</a:t>
             </a:r>
           </a:p>
           <a:p>
@@ -3714,7 +3730,7 @@
               </a:defRPr>
             </a:pPr>
             <a:r>
-              <a:t>• Justificación: Los Named Volumes aíslan los datos del host,</a:t>
+              <a:t>• Justificación: Named Volumes aíslan datos del host Linux,</a:t>
             </a:r>
           </a:p>
           <a:p>
@@ -3746,7 +3762,7 @@
               </a:defRPr>
             </a:pPr>
             <a:r>
-              <a:t>• Garantiza la continuidad operativa ante fallos.</a:t>
+              <a:t>• Alta Disponibilidad: Datos sobreviven a redespliegues.</a:t>
             </a:r>
           </a:p>
         </p:txBody>
@@ -3793,7 +3809,7 @@
               </a:defRPr>
             </a:pPr>
             <a:r>
-              <a:t>[IE3] Pipeline CI/CD en GitHub Actions</a:t>
+              <a:t>[IE3] Pipeline CI/CD: 3 Flujos</a:t>
             </a:r>
           </a:p>
         </p:txBody>
@@ -3826,7 +3842,7 @@
               </a:defRPr>
             </a:pPr>
             <a:r>
-              <a:t>Triggers: Activación exclusiva en la rama 'deploy'.</a:t>
+              <a:t>Pipelines Independientes por Microservicio:</a:t>
             </a:r>
           </a:p>
           <a:p>
@@ -3842,7 +3858,7 @@
               </a:defRPr>
             </a:pPr>
             <a:r>
-              <a:t>Gestión de Secrets: </a:t>
+              <a:t>• cicd-tienda-frontend.yml</a:t>
             </a:r>
           </a:p>
           <a:p>
@@ -3858,7 +3874,7 @@
               </a:defRPr>
             </a:pPr>
             <a:r>
-              <a:t>• Credenciales de AWS y Tokens protegidos.</a:t>
+              <a:t>• cicd-tienda-backend-ventas.yml</a:t>
             </a:r>
           </a:p>
           <a:p>
@@ -3874,7 +3890,7 @@
               </a:defRPr>
             </a:pPr>
             <a:r>
-              <a:t>Fases del Pipeline:</a:t>
+              <a:t>• cicd-tienda-backend-despachos.yml</a:t>
             </a:r>
           </a:p>
           <a:p>
@@ -3890,7 +3906,7 @@
               </a:defRPr>
             </a:pPr>
             <a:r>
-              <a:t>1. Build Docker (Multi-stage).</a:t>
+              <a:t>Flujo (Push a rama 'deploy'):</a:t>
             </a:r>
           </a:p>
           <a:p>
@@ -3906,7 +3922,7 @@
               </a:defRPr>
             </a:pPr>
             <a:r>
-              <a:t>2. Push: Publicación en Amazon ECR.</a:t>
+              <a:t>1. Build &amp; Push imagen a Amazon ECR.</a:t>
             </a:r>
           </a:p>
           <a:p>
@@ -3922,7 +3938,7 @@
               </a:defRPr>
             </a:pPr>
             <a:r>
-              <a:t>3. Deploy: Actualización automática en Amazon EC2.</a:t>
+              <a:t>2. Trigger SSM para EC2: Docker Compose Pull &amp; Up.</a:t>
             </a:r>
           </a:p>
         </p:txBody>
@@ -3993,7 +4009,7 @@
               </a:defRPr>
             </a:pPr>
             <a:r>
-              <a:t>[IE7] Justificación Técnica del Pipeline</a:t>
+              <a:t>[IE7] Justificación Técnica del Despliegue</a:t>
             </a:r>
           </a:p>
         </p:txBody>
@@ -4042,7 +4058,7 @@
               </a:defRPr>
             </a:pPr>
             <a:r>
-              <a:t>• Integración nativa con IAM y menor latencia hacia EC2.</a:t>
+              <a:t>• Integración nativa con IAM y latencia cero hacia EC2.</a:t>
             </a:r>
           </a:p>
           <a:p>
@@ -4058,7 +4074,7 @@
               </a:defRPr>
             </a:pPr>
             <a:r>
-              <a:t>¿Por qué este diseño automatiza la entrega continua?</a:t>
+              <a:t>¿Por qué AWS Systems Manager (SSM)?</a:t>
             </a:r>
           </a:p>
           <a:p>
@@ -4074,7 +4090,7 @@
               </a:defRPr>
             </a:pPr>
             <a:r>
-              <a:t>• Elimina la intervención humana post-commit.</a:t>
+              <a:t>• Permite comandos remotos automatizados en EC2.</a:t>
             </a:r>
           </a:p>
           <a:p>
@@ -4090,7 +4106,7 @@
               </a:defRPr>
             </a:pPr>
             <a:r>
-              <a:t>• AWS Systems Manager (SSM) despliega sin requerir abrir </a:t>
+              <a:t>• Innovatech Chile no necesita abrir puertos SSH al mundo,</a:t>
             </a:r>
           </a:p>
           <a:p>
@@ -4106,7 +4122,7 @@
               </a:defRPr>
             </a:pPr>
             <a:r>
-              <a:t>  el puerto 22 (SSH), mitigando riesgos críticos para Innovatech.</a:t>
+              <a:t>  mitigando vulnerabilidades críticas en producción.</a:t>
             </a:r>
           </a:p>
         </p:txBody>
@@ -4210,7 +4226,7 @@
               </a:defRPr>
             </a:pPr>
             <a:r>
-              <a:t>A. Contenedorización: Docker resuelve el 'en mi máquina funciona'.</a:t>
+              <a:t>1. Microservicios: Desacoplamiento Ventas/Despachos.</a:t>
             </a:r>
           </a:p>
           <a:p>
@@ -4226,7 +4242,7 @@
               </a:defRPr>
             </a:pPr>
             <a:r>
-              <a:t>B. Gestión de Entornos: Configuración inyectada vía variables.</a:t>
+              <a:t>2. Shift-Left Security: Alpine Linux y usuarios Non-Root.</a:t>
             </a:r>
           </a:p>
           <a:p>
@@ -4242,7 +4258,7 @@
               </a:defRPr>
             </a:pPr>
             <a:r>
-              <a:t>C. CI/CD: Automatización reduce el 'Lead Time for Changes'.</a:t>
+              <a:t>3. Entrega Continua: Lead Time minimizado con GH Actions.</a:t>
             </a:r>
           </a:p>
           <a:p>
@@ -4258,7 +4274,7 @@
               </a:defRPr>
             </a:pPr>
             <a:r>
-              <a:t>D. Control de Versiones: Git centralizado.</a:t>
+              <a:t>4. IaC: Todo orquestado nativamente con Compose.</a:t>
             </a:r>
           </a:p>
           <a:p>
@@ -4274,7 +4290,7 @@
               </a:defRPr>
             </a:pPr>
             <a:r>
-              <a:t>E. Persistencia Segura: Volúmenes externos al ciclo efímero.</a:t>
+              <a:t>Escalabilidad: La arquitectura Spring Boot + React está</a:t>
             </a:r>
           </a:p>
           <a:p>
@@ -4290,7 +4306,7 @@
               </a:defRPr>
             </a:pPr>
             <a:r>
-              <a:t>Impacto: Favorece la escalabilidad y mantenibilidad en AWS.</a:t>
+              <a:t>lista para la Nube.</a:t>
             </a:r>
           </a:p>
         </p:txBody>
@@ -4337,7 +4353,7 @@
               </a:defRPr>
             </a:pPr>
             <a:r>
-              <a:t>[IE4/IE9] Funcionamiento en EC2</a:t>
+              <a:t>[IE4/IE9] Funcionamiento de Microservicios</a:t>
             </a:r>
           </a:p>
         </p:txBody>
@@ -4370,7 +4386,7 @@
               </a:defRPr>
             </a:pPr>
             <a:r>
-              <a:t>El contenedor Frontend opera públicamente respondiendo peticiones.</a:t>
+              <a:t>El Nginx (Frontend) es el único expuesto al público.</a:t>
             </a:r>
           </a:p>
           <a:p>
@@ -4386,7 +4402,7 @@
               </a:defRPr>
             </a:pPr>
             <a:r>
-              <a:t>El Backend y Base de Datos están restringidos por Security Groups.</a:t>
+              <a:t>Ambos backends Spring Boot (8080 y 8081) y MySQL (3306)</a:t>
             </a:r>
           </a:p>
           <a:p>
@@ -4402,7 +4418,23 @@
               </a:defRPr>
             </a:pPr>
             <a:r>
-              <a:t>Los endpoints son consumidos exitosamente por la SPA estática.</a:t>
+              <a:t>están ocultos en la subred privada de Docker.</a:t>
+            </a:r>
+          </a:p>
+          <a:p>
+            <a:pPr>
+              <a:spcAft>
+                <a:spcPts val="1400"/>
+              </a:spcAft>
+              <a:defRPr sz="2000">
+                <a:solidFill>
+                  <a:srgbClr val="3C3C3C"/>
+                </a:solidFill>
+                <a:latin typeface="Arial"/>
+              </a:defRPr>
+            </a:pPr>
+            <a:r>
+              <a:t>El Proxy de Nginx resuelve peticiones /api/ internamente.</a:t>
             </a:r>
           </a:p>
         </p:txBody>
@@ -4506,7 +4538,7 @@
               </a:defRPr>
             </a:pPr>
             <a:r>
-              <a:t>Verificación mediante 'docker ps' y 'docker volume ls'.</a:t>
+              <a:t>Verificación mediante 'docker ps' y 'docker images'.</a:t>
             </a:r>
           </a:p>
           <a:p>
@@ -4522,7 +4554,7 @@
               </a:defRPr>
             </a:pPr>
             <a:r>
-              <a:t>Todos los contenedores muestran estado '(healthy)'.</a:t>
+              <a:t>Se aprecian 4 contenedores en ejecución paralela.</a:t>
             </a:r>
           </a:p>
         </p:txBody>
@@ -4544,7 +4576,7 @@
         <p:spPr>
           <a:xfrm>
             <a:off x="4114800" y="2286000"/>
-            <a:ext cx="29260800" cy="3657600"/>
+            <a:ext cx="26894118" cy="3657600"/>
           </a:xfrm>
           <a:prstGeom prst="rect">
             <a:avLst/>

</xml_diff>